<commit_message>
Update Module 7 presentation file with new content
</commit_message>
<xml_diff>
--- a/Module 7/Rozendaal_Mod7_2_CSD380.pptx
+++ b/Module 7/Rozendaal_Mod7_2_CSD380.pptx
@@ -111,6 +111,11 @@
       </a:defRPr>
     </a:lvl9pPr>
   </p:defaultTextStyle>
+  <p:extLst>
+    <p:ext uri="{EFAFB233-063F-42B5-8137-9DF3F51BA10A}">
+      <p15:sldGuideLst xmlns:p15="http://schemas.microsoft.com/office/powerpoint/2012/main"/>
+    </p:ext>
+  </p:extLst>
 </p:presentation>
 </file>
 
@@ -17981,7 +17986,7 @@
           <a:p>
             <a:fld id="{82E99DD5-0AB9-4D0E-9BE0-FF7AF4690BE4}" type="datetimeFigureOut">
               <a:rPr lang="en-US" smtClean="0"/>
-              <a:t>6/22/2026</a:t>
+              <a:t>7/6/2026</a:t>
             </a:fld>
             <a:endParaRPr lang="en-US"/>
           </a:p>
@@ -18179,7 +18184,7 @@
           <a:p>
             <a:fld id="{82E99DD5-0AB9-4D0E-9BE0-FF7AF4690BE4}" type="datetimeFigureOut">
               <a:rPr lang="en-US" smtClean="0"/>
-              <a:t>6/22/2026</a:t>
+              <a:t>7/6/2026</a:t>
             </a:fld>
             <a:endParaRPr lang="en-US"/>
           </a:p>
@@ -18387,7 +18392,7 @@
           <a:p>
             <a:fld id="{82E99DD5-0AB9-4D0E-9BE0-FF7AF4690BE4}" type="datetimeFigureOut">
               <a:rPr lang="en-US" smtClean="0"/>
-              <a:t>6/22/2026</a:t>
+              <a:t>7/6/2026</a:t>
             </a:fld>
             <a:endParaRPr lang="en-US"/>
           </a:p>
@@ -18585,7 +18590,7 @@
           <a:p>
             <a:fld id="{82E99DD5-0AB9-4D0E-9BE0-FF7AF4690BE4}" type="datetimeFigureOut">
               <a:rPr lang="en-US" smtClean="0"/>
-              <a:t>6/22/2026</a:t>
+              <a:t>7/6/2026</a:t>
             </a:fld>
             <a:endParaRPr lang="en-US"/>
           </a:p>
@@ -18860,7 +18865,7 @@
           <a:p>
             <a:fld id="{82E99DD5-0AB9-4D0E-9BE0-FF7AF4690BE4}" type="datetimeFigureOut">
               <a:rPr lang="en-US" smtClean="0"/>
-              <a:t>6/22/2026</a:t>
+              <a:t>7/6/2026</a:t>
             </a:fld>
             <a:endParaRPr lang="en-US"/>
           </a:p>
@@ -19125,7 +19130,7 @@
           <a:p>
             <a:fld id="{82E99DD5-0AB9-4D0E-9BE0-FF7AF4690BE4}" type="datetimeFigureOut">
               <a:rPr lang="en-US" smtClean="0"/>
-              <a:t>6/22/2026</a:t>
+              <a:t>7/6/2026</a:t>
             </a:fld>
             <a:endParaRPr lang="en-US"/>
           </a:p>
@@ -19537,7 +19542,7 @@
           <a:p>
             <a:fld id="{82E99DD5-0AB9-4D0E-9BE0-FF7AF4690BE4}" type="datetimeFigureOut">
               <a:rPr lang="en-US" smtClean="0"/>
-              <a:t>6/22/2026</a:t>
+              <a:t>7/6/2026</a:t>
             </a:fld>
             <a:endParaRPr lang="en-US"/>
           </a:p>
@@ -19678,7 +19683,7 @@
           <a:p>
             <a:fld id="{82E99DD5-0AB9-4D0E-9BE0-FF7AF4690BE4}" type="datetimeFigureOut">
               <a:rPr lang="en-US" smtClean="0"/>
-              <a:t>6/22/2026</a:t>
+              <a:t>7/6/2026</a:t>
             </a:fld>
             <a:endParaRPr lang="en-US"/>
           </a:p>
@@ -19791,7 +19796,7 @@
           <a:p>
             <a:fld id="{82E99DD5-0AB9-4D0E-9BE0-FF7AF4690BE4}" type="datetimeFigureOut">
               <a:rPr lang="en-US" smtClean="0"/>
-              <a:t>6/22/2026</a:t>
+              <a:t>7/6/2026</a:t>
             </a:fld>
             <a:endParaRPr lang="en-US"/>
           </a:p>
@@ -20102,7 +20107,7 @@
           <a:p>
             <a:fld id="{82E99DD5-0AB9-4D0E-9BE0-FF7AF4690BE4}" type="datetimeFigureOut">
               <a:rPr lang="en-US" smtClean="0"/>
-              <a:t>6/22/2026</a:t>
+              <a:t>7/6/2026</a:t>
             </a:fld>
             <a:endParaRPr lang="en-US"/>
           </a:p>
@@ -20390,7 +20395,7 @@
           <a:p>
             <a:fld id="{82E99DD5-0AB9-4D0E-9BE0-FF7AF4690BE4}" type="datetimeFigureOut">
               <a:rPr lang="en-US" smtClean="0"/>
-              <a:t>6/22/2026</a:t>
+              <a:t>7/6/2026</a:t>
             </a:fld>
             <a:endParaRPr lang="en-US"/>
           </a:p>
@@ -20631,7 +20636,7 @@
           <a:p>
             <a:fld id="{82E99DD5-0AB9-4D0E-9BE0-FF7AF4690BE4}" type="datetimeFigureOut">
               <a:rPr lang="en-US" smtClean="0"/>
-              <a:t>6/22/2026</a:t>
+              <a:t>7/6/2026</a:t>
             </a:fld>
             <a:endParaRPr lang="en-US"/>
           </a:p>
@@ -47425,32 +47430,8 @@
           <a:lstStyle/>
           <a:p>
             <a:r>
-              <a:rPr lang="en-US" i="1" dirty="0"/>
-              <a:t>On-Call Rotations and Schedules</a:t>
-            </a:r>
-            <a:r>
               <a:rPr lang="en-US" dirty="0"/>
-              <a:t>. (2025, September 4). PagerDuty. https://www.pagerduty.com/resources/incident-management-response/learn/call-rotations-schedules</a:t>
-            </a:r>
-          </a:p>
-          <a:p>
-            <a:r>
-              <a:rPr lang="en-US" dirty="0"/>
-              <a:t>‌ Shah, N. (2026, March 6). </a:t>
-            </a:r>
-            <a:r>
-              <a:rPr lang="en-US" i="1" dirty="0"/>
-              <a:t>On-Call Rotation Best Practices: Reducing Burnout and Improving Response  - DevOps.com</a:t>
-            </a:r>
-            <a:r>
-              <a:rPr lang="en-US" dirty="0"/>
-              <a:t>. DevOps.com. https://devops.com/on-call-rotation-best-practices-reducing-burnout-and-improving-response</a:t>
-            </a:r>
-          </a:p>
-          <a:p>
-            <a:r>
-              <a:rPr lang="en-US" dirty="0"/>
-              <a:t>‌ Cook, O., Smollett, S., Spadaccini, A., Donnelly, C., Ma, J., Evernote, G. P., Thorne, S., &amp; Yang, J. (2016). </a:t>
+              <a:t>‌Cook, O., Smollett, S., Spadaccini, A., Donnelly, C., Ma, J., Evernote, G. P., Thorne, S., &amp; Yang, J. (2016). </a:t>
             </a:r>
             <a:r>
               <a:rPr lang="en-US" i="1" dirty="0"/>
@@ -47476,7 +47457,7 @@
             </a:r>
             <a:r>
               <a:rPr lang="en-US" b="1" dirty="0"/>
-              <a:t> Microsoft. (2026). </a:t>
+              <a:t>Microsoft. (2026). </a:t>
             </a:r>
             <a:r>
               <a:rPr lang="en-US" b="1" i="1" dirty="0"/>
@@ -47493,6 +47474,30 @@
               <a:t>https://copilot.microsoft.com</a:t>
             </a:r>
             <a:endParaRPr lang="en-US" dirty="0"/>
+          </a:p>
+          <a:p>
+            <a:r>
+              <a:rPr lang="en-US" i="1" dirty="0"/>
+              <a:t>On-Call Rotations and Schedules</a:t>
+            </a:r>
+            <a:r>
+              <a:rPr lang="en-US" dirty="0"/>
+              <a:t>. (2025, September 4). PagerDuty. https://www.pagerduty.com/resources/incident-management-response/learn/call-rotations-schedules</a:t>
+            </a:r>
+          </a:p>
+          <a:p>
+            <a:r>
+              <a:rPr lang="en-US" dirty="0"/>
+              <a:t>‌Shah, N. (2026, March 6). </a:t>
+            </a:r>
+            <a:r>
+              <a:rPr lang="en-US" i="1" dirty="0"/>
+              <a:t>On-Call Rotation Best Practices: Reducing Burnout and Improving Response  - DevOps.com</a:t>
+            </a:r>
+            <a:r>
+              <a:rPr lang="en-US" dirty="0"/>
+              <a:t>. DevOps.com. https://devops.com/on-call-rotation-best-practices-reducing-burnout-and-improving-response</a:t>
+            </a:r>
           </a:p>
         </p:txBody>
       </p:sp>

</xml_diff>